<commit_message>
Update slides template: shorten bar/separator for logo, fix page number position
Consistent with slides 6/7 branding: top bar stops before logo area,
header separator shortened, top-right corner brackets removed, page
number aligned to x=12.13in.

Co-Authored-By: Claude Opus 4.6 <noreply@anthropic.com>
</commit_message>
<xml_diff>
--- a/branding/TAQUANT SLIDES TEMPLATE.pptx
+++ b/branding/TAQUANT SLIDES TEMPLATE.pptx
@@ -3772,7 +3772,7 @@
         <p:spPr>
           <a:xfrm>
             <a:off x="0" y="0"/>
-            <a:ext cx="12191695" cy="36576"/>
+            <a:ext cx="11466576" cy="36576"/>
           </a:xfrm>
           <a:prstGeom prst="rect">
             <a:avLst/>
@@ -3877,7 +3877,7 @@
         <p:spPr>
           <a:xfrm>
             <a:off x="365760" y="411480"/>
-            <a:ext cx="11460175" cy="0"/>
+            <a:ext cx="10881360" cy="0"/>
           </a:xfrm>
           <a:prstGeom prst="line">
             <a:avLst/>
@@ -3960,13 +3960,13 @@
       </p:sp>
       <p:sp>
         <p:nvSpPr>
-          <p:cNvPr id="8" name="Shape 6"/>
-          <p:cNvSpPr/>
-          <p:nvPr/>
-        </p:nvSpPr>
-        <p:spPr>
-          <a:xfrm>
-            <a:off x="11853367" y="228600"/>
+          <p:cNvPr id="10" name="Shape 8"/>
+          <p:cNvSpPr/>
+          <p:nvPr/>
+        </p:nvSpPr>
+        <p:spPr>
+          <a:xfrm>
+            <a:off x="228600" y="6629400"/>
             <a:ext cx="109728" cy="0"/>
           </a:xfrm>
           <a:prstGeom prst="line">
@@ -3990,13 +3990,13 @@
       </p:sp>
       <p:sp>
         <p:nvSpPr>
-          <p:cNvPr id="9" name="Shape 7"/>
-          <p:cNvSpPr/>
-          <p:nvPr/>
-        </p:nvSpPr>
-        <p:spPr>
-          <a:xfrm>
-            <a:off x="11963095" y="228600"/>
+          <p:cNvPr id="11" name="Shape 9"/>
+          <p:cNvSpPr/>
+          <p:nvPr/>
+        </p:nvSpPr>
+        <p:spPr>
+          <a:xfrm>
+            <a:off x="228600" y="6519672"/>
             <a:ext cx="0" cy="109728"/>
           </a:xfrm>
           <a:prstGeom prst="line">
@@ -4020,13 +4020,13 @@
       </p:sp>
       <p:sp>
         <p:nvSpPr>
-          <p:cNvPr id="10" name="Shape 8"/>
-          <p:cNvSpPr/>
-          <p:nvPr/>
-        </p:nvSpPr>
-        <p:spPr>
-          <a:xfrm>
-            <a:off x="228600" y="6629400"/>
+          <p:cNvPr id="12" name="Shape 10"/>
+          <p:cNvSpPr/>
+          <p:nvPr/>
+        </p:nvSpPr>
+        <p:spPr>
+          <a:xfrm>
+            <a:off x="11853367" y="6629400"/>
             <a:ext cx="109728" cy="0"/>
           </a:xfrm>
           <a:prstGeom prst="line">
@@ -4050,13 +4050,13 @@
       </p:sp>
       <p:sp>
         <p:nvSpPr>
-          <p:cNvPr id="11" name="Shape 9"/>
-          <p:cNvSpPr/>
-          <p:nvPr/>
-        </p:nvSpPr>
-        <p:spPr>
-          <a:xfrm>
-            <a:off x="228600" y="6519672"/>
+          <p:cNvPr id="13" name="Shape 11"/>
+          <p:cNvSpPr/>
+          <p:nvPr/>
+        </p:nvSpPr>
+        <p:spPr>
+          <a:xfrm>
+            <a:off x="11963095" y="6519672"/>
             <a:ext cx="0" cy="109728"/>
           </a:xfrm>
           <a:prstGeom prst="line">
@@ -4080,66 +4080,6 @@
       </p:sp>
       <p:sp>
         <p:nvSpPr>
-          <p:cNvPr id="12" name="Shape 10"/>
-          <p:cNvSpPr/>
-          <p:nvPr/>
-        </p:nvSpPr>
-        <p:spPr>
-          <a:xfrm>
-            <a:off x="11853367" y="6629400"/>
-            <a:ext cx="109728" cy="0"/>
-          </a:xfrm>
-          <a:prstGeom prst="line">
-            <a:avLst/>
-          </a:prstGeom>
-          <a:noFill/>
-          <a:ln w="6350">
-            <a:solidFill>
-              <a:srgbClr val="1E6F96"/>
-            </a:solidFill>
-            <a:prstDash val="solid"/>
-          </a:ln>
-        </p:spPr>
-        <p:txBody>
-          <a:bodyPr/>
-          <a:lstStyle/>
-          <a:p>
-            <a:endParaRPr lang="en-US"/>
-          </a:p>
-        </p:txBody>
-      </p:sp>
-      <p:sp>
-        <p:nvSpPr>
-          <p:cNvPr id="13" name="Shape 11"/>
-          <p:cNvSpPr/>
-          <p:nvPr/>
-        </p:nvSpPr>
-        <p:spPr>
-          <a:xfrm>
-            <a:off x="11963095" y="6519672"/>
-            <a:ext cx="0" cy="109728"/>
-          </a:xfrm>
-          <a:prstGeom prst="line">
-            <a:avLst/>
-          </a:prstGeom>
-          <a:noFill/>
-          <a:ln w="6350">
-            <a:solidFill>
-              <a:srgbClr val="1E6F96"/>
-            </a:solidFill>
-            <a:prstDash val="solid"/>
-          </a:ln>
-        </p:spPr>
-        <p:txBody>
-          <a:bodyPr/>
-          <a:lstStyle/>
-          <a:p>
-            <a:endParaRPr lang="en-US"/>
-          </a:p>
-        </p:txBody>
-      </p:sp>
-      <p:sp>
-        <p:nvSpPr>
           <p:cNvPr id="14" name="Shape 12"/>
           <p:cNvSpPr/>
           <p:nvPr/>
@@ -4215,7 +4155,7 @@
         </p:nvSpPr>
         <p:spPr>
           <a:xfrm>
-            <a:off x="11094415" y="6537960"/>
+            <a:off x="11091672" y="6537960"/>
             <a:ext cx="731520" cy="201168"/>
           </a:xfrm>
           <a:prstGeom prst="rect">
@@ -4537,7 +4477,7 @@
         <p:spPr>
           <a:xfrm>
             <a:off x="0" y="0"/>
-            <a:ext cx="12191695" cy="36576"/>
+            <a:ext cx="11466576" cy="36576"/>
           </a:xfrm>
           <a:prstGeom prst="rect">
             <a:avLst/>
@@ -4666,7 +4606,7 @@
         <p:spPr>
           <a:xfrm>
             <a:off x="365760" y="411480"/>
-            <a:ext cx="11460175" cy="0"/>
+            <a:ext cx="10881360" cy="0"/>
           </a:xfrm>
           <a:prstGeom prst="line">
             <a:avLst/>
@@ -4944,7 +4884,7 @@
         </p:nvSpPr>
         <p:spPr>
           <a:xfrm>
-            <a:off x="11094415" y="6537960"/>
+            <a:off x="11091672" y="6537960"/>
             <a:ext cx="731520" cy="201168"/>
           </a:xfrm>
           <a:prstGeom prst="rect">
@@ -5272,7 +5212,7 @@
         <p:spPr>
           <a:xfrm>
             <a:off x="0" y="0"/>
-            <a:ext cx="12191695" cy="36576"/>
+            <a:ext cx="11466576" cy="36576"/>
           </a:xfrm>
           <a:prstGeom prst="rect">
             <a:avLst/>
@@ -5401,7 +5341,7 @@
         <p:spPr>
           <a:xfrm>
             <a:off x="365760" y="411480"/>
-            <a:ext cx="11460175" cy="0"/>
+            <a:ext cx="10881360" cy="0"/>
           </a:xfrm>
           <a:prstGeom prst="line">
             <a:avLst/>
@@ -5679,7 +5619,7 @@
         </p:nvSpPr>
         <p:spPr>
           <a:xfrm>
-            <a:off x="11094415" y="6537960"/>
+            <a:off x="11091672" y="6537960"/>
             <a:ext cx="731520" cy="201168"/>
           </a:xfrm>
           <a:prstGeom prst="rect">
@@ -6190,7 +6130,7 @@
         <p:spPr>
           <a:xfrm>
             <a:off x="0" y="0"/>
-            <a:ext cx="12191695" cy="36576"/>
+            <a:ext cx="11466576" cy="36576"/>
           </a:xfrm>
           <a:prstGeom prst="rect">
             <a:avLst/>
@@ -6319,7 +6259,7 @@
         <p:spPr>
           <a:xfrm>
             <a:off x="365760" y="411480"/>
-            <a:ext cx="11460175" cy="0"/>
+            <a:ext cx="10881360" cy="0"/>
           </a:xfrm>
           <a:prstGeom prst="line">
             <a:avLst/>
@@ -6597,7 +6537,7 @@
         </p:nvSpPr>
         <p:spPr>
           <a:xfrm>
-            <a:off x="11094415" y="6537960"/>
+            <a:off x="11091672" y="6537960"/>
             <a:ext cx="731520" cy="201168"/>
           </a:xfrm>
           <a:prstGeom prst="rect">
@@ -7404,7 +7344,7 @@
         <p:spPr>
           <a:xfrm>
             <a:off x="0" y="0"/>
-            <a:ext cx="12191695" cy="36576"/>
+            <a:ext cx="11466576" cy="36576"/>
           </a:xfrm>
           <a:prstGeom prst="rect">
             <a:avLst/>
@@ -7533,7 +7473,7 @@
         <p:spPr>
           <a:xfrm>
             <a:off x="365760" y="411480"/>
-            <a:ext cx="11460175" cy="0"/>
+            <a:ext cx="10881360" cy="0"/>
           </a:xfrm>
           <a:prstGeom prst="line">
             <a:avLst/>
@@ -7811,7 +7751,7 @@
         </p:nvSpPr>
         <p:spPr>
           <a:xfrm>
-            <a:off x="11094415" y="6537960"/>
+            <a:off x="11091672" y="6537960"/>
             <a:ext cx="731520" cy="201168"/>
           </a:xfrm>
           <a:prstGeom prst="rect">
@@ -8086,7 +8026,7 @@
         <p:spPr>
           <a:xfrm>
             <a:off x="0" y="0"/>
-            <a:ext cx="12191695" cy="36576"/>
+            <a:ext cx="11466576" cy="36576"/>
           </a:xfrm>
           <a:prstGeom prst="rect">
             <a:avLst/>
@@ -8215,7 +8155,7 @@
         <p:spPr>
           <a:xfrm>
             <a:off x="365760" y="411480"/>
-            <a:ext cx="11460175" cy="0"/>
+            <a:ext cx="10881360" cy="0"/>
           </a:xfrm>
           <a:prstGeom prst="line">
             <a:avLst/>
@@ -8493,7 +8433,7 @@
         </p:nvSpPr>
         <p:spPr>
           <a:xfrm>
-            <a:off x="11094415" y="6537960"/>
+            <a:off x="11091672" y="6537960"/>
             <a:ext cx="731520" cy="201168"/>
           </a:xfrm>
           <a:prstGeom prst="rect">
@@ -8729,7 +8669,7 @@
         <p:spPr>
           <a:xfrm>
             <a:off x="0" y="0"/>
-            <a:ext cx="12191695" cy="36576"/>
+            <a:ext cx="11466576" cy="36576"/>
           </a:xfrm>
           <a:prstGeom prst="rect">
             <a:avLst/>
@@ -8858,7 +8798,7 @@
         <p:spPr>
           <a:xfrm>
             <a:off x="365760" y="411480"/>
-            <a:ext cx="11460175" cy="0"/>
+            <a:ext cx="10881360" cy="0"/>
           </a:xfrm>
           <a:prstGeom prst="line">
             <a:avLst/>
@@ -9136,7 +9076,7 @@
         </p:nvSpPr>
         <p:spPr>
           <a:xfrm>
-            <a:off x="11094415" y="6537960"/>
+            <a:off x="11091672" y="6537960"/>
             <a:ext cx="731520" cy="201168"/>
           </a:xfrm>
           <a:prstGeom prst="rect">
@@ -12223,7 +12163,7 @@
         <p:spPr>
           <a:xfrm>
             <a:off x="0" y="0"/>
-            <a:ext cx="12191695" cy="36576"/>
+            <a:ext cx="11466576" cy="36576"/>
           </a:xfrm>
           <a:prstGeom prst="rect">
             <a:avLst/>
@@ -12352,7 +12292,7 @@
         <p:spPr>
           <a:xfrm>
             <a:off x="365760" y="411480"/>
-            <a:ext cx="11460175" cy="0"/>
+            <a:ext cx="10881360" cy="0"/>
           </a:xfrm>
           <a:prstGeom prst="line">
             <a:avLst/>
@@ -12630,7 +12570,7 @@
         </p:nvSpPr>
         <p:spPr>
           <a:xfrm>
-            <a:off x="11094415" y="6537960"/>
+            <a:off x="11091672" y="6537960"/>
             <a:ext cx="731520" cy="201168"/>
           </a:xfrm>
           <a:prstGeom prst="rect">
@@ -12960,7 +12900,7 @@
         <p:spPr>
           <a:xfrm>
             <a:off x="0" y="0"/>
-            <a:ext cx="12191695" cy="36576"/>
+            <a:ext cx="11466576" cy="36576"/>
           </a:xfrm>
           <a:prstGeom prst="rect">
             <a:avLst/>
@@ -13089,7 +13029,7 @@
         <p:spPr>
           <a:xfrm>
             <a:off x="365760" y="411480"/>
-            <a:ext cx="11460175" cy="0"/>
+            <a:ext cx="10881360" cy="0"/>
           </a:xfrm>
           <a:prstGeom prst="line">
             <a:avLst/>
@@ -13367,7 +13307,7 @@
         </p:nvSpPr>
         <p:spPr>
           <a:xfrm>
-            <a:off x="11094415" y="6537960"/>
+            <a:off x="11091672" y="6537960"/>
             <a:ext cx="731520" cy="201168"/>
           </a:xfrm>
           <a:prstGeom prst="rect">
@@ -14039,7 +13979,7 @@
         <p:spPr>
           <a:xfrm>
             <a:off x="0" y="0"/>
-            <a:ext cx="12191695" cy="36576"/>
+            <a:ext cx="11466576" cy="36576"/>
           </a:xfrm>
           <a:prstGeom prst="rect">
             <a:avLst/>
@@ -14168,7 +14108,7 @@
         <p:spPr>
           <a:xfrm>
             <a:off x="365760" y="411480"/>
-            <a:ext cx="11460175" cy="0"/>
+            <a:ext cx="10881360" cy="0"/>
           </a:xfrm>
           <a:prstGeom prst="line">
             <a:avLst/>
@@ -14446,7 +14386,7 @@
         </p:nvSpPr>
         <p:spPr>
           <a:xfrm>
-            <a:off x="11094415" y="6537960"/>
+            <a:off x="11091672" y="6537960"/>
             <a:ext cx="731520" cy="201168"/>
           </a:xfrm>
           <a:prstGeom prst="rect">
@@ -15453,7 +15393,7 @@
         <p:spPr>
           <a:xfrm>
             <a:off x="0" y="0"/>
-            <a:ext cx="12191695" cy="36576"/>
+            <a:ext cx="11466576" cy="36576"/>
           </a:xfrm>
           <a:prstGeom prst="rect">
             <a:avLst/>
@@ -15582,7 +15522,7 @@
         <p:spPr>
           <a:xfrm>
             <a:off x="365760" y="411480"/>
-            <a:ext cx="11460175" cy="0"/>
+            <a:ext cx="10881360" cy="0"/>
           </a:xfrm>
           <a:prstGeom prst="line">
             <a:avLst/>
@@ -15860,7 +15800,7 @@
         </p:nvSpPr>
         <p:spPr>
           <a:xfrm>
-            <a:off x="11094415" y="6537960"/>
+            <a:off x="11091672" y="6537960"/>
             <a:ext cx="731520" cy="201168"/>
           </a:xfrm>
           <a:prstGeom prst="rect">
@@ -16206,7 +16146,7 @@
         <p:spPr>
           <a:xfrm>
             <a:off x="0" y="0"/>
-            <a:ext cx="12191695" cy="36576"/>
+            <a:ext cx="11466576" cy="36576"/>
           </a:xfrm>
           <a:prstGeom prst="rect">
             <a:avLst/>
@@ -16311,7 +16251,7 @@
         <p:spPr>
           <a:xfrm>
             <a:off x="365760" y="411480"/>
-            <a:ext cx="11460175" cy="0"/>
+            <a:ext cx="10881360" cy="0"/>
           </a:xfrm>
           <a:prstGeom prst="line">
             <a:avLst/>
@@ -16394,13 +16334,13 @@
       </p:sp>
       <p:sp>
         <p:nvSpPr>
-          <p:cNvPr id="8" name="Shape 6"/>
-          <p:cNvSpPr/>
-          <p:nvPr/>
-        </p:nvSpPr>
-        <p:spPr>
-          <a:xfrm>
-            <a:off x="11853367" y="228600"/>
+          <p:cNvPr id="10" name="Shape 8"/>
+          <p:cNvSpPr/>
+          <p:nvPr/>
+        </p:nvSpPr>
+        <p:spPr>
+          <a:xfrm>
+            <a:off x="228600" y="6629400"/>
             <a:ext cx="109728" cy="0"/>
           </a:xfrm>
           <a:prstGeom prst="line">
@@ -16424,13 +16364,13 @@
       </p:sp>
       <p:sp>
         <p:nvSpPr>
-          <p:cNvPr id="9" name="Shape 7"/>
-          <p:cNvSpPr/>
-          <p:nvPr/>
-        </p:nvSpPr>
-        <p:spPr>
-          <a:xfrm>
-            <a:off x="11963095" y="228600"/>
+          <p:cNvPr id="11" name="Shape 9"/>
+          <p:cNvSpPr/>
+          <p:nvPr/>
+        </p:nvSpPr>
+        <p:spPr>
+          <a:xfrm>
+            <a:off x="228600" y="6519672"/>
             <a:ext cx="0" cy="109728"/>
           </a:xfrm>
           <a:prstGeom prst="line">
@@ -16454,13 +16394,13 @@
       </p:sp>
       <p:sp>
         <p:nvSpPr>
-          <p:cNvPr id="10" name="Shape 8"/>
-          <p:cNvSpPr/>
-          <p:nvPr/>
-        </p:nvSpPr>
-        <p:spPr>
-          <a:xfrm>
-            <a:off x="228600" y="6629400"/>
+          <p:cNvPr id="12" name="Shape 10"/>
+          <p:cNvSpPr/>
+          <p:nvPr/>
+        </p:nvSpPr>
+        <p:spPr>
+          <a:xfrm>
+            <a:off x="11853367" y="6629400"/>
             <a:ext cx="109728" cy="0"/>
           </a:xfrm>
           <a:prstGeom prst="line">
@@ -16484,13 +16424,13 @@
       </p:sp>
       <p:sp>
         <p:nvSpPr>
-          <p:cNvPr id="11" name="Shape 9"/>
-          <p:cNvSpPr/>
-          <p:nvPr/>
-        </p:nvSpPr>
-        <p:spPr>
-          <a:xfrm>
-            <a:off x="228600" y="6519672"/>
+          <p:cNvPr id="13" name="Shape 11"/>
+          <p:cNvSpPr/>
+          <p:nvPr/>
+        </p:nvSpPr>
+        <p:spPr>
+          <a:xfrm>
+            <a:off x="11963095" y="6519672"/>
             <a:ext cx="0" cy="109728"/>
           </a:xfrm>
           <a:prstGeom prst="line">
@@ -16514,66 +16454,6 @@
       </p:sp>
       <p:sp>
         <p:nvSpPr>
-          <p:cNvPr id="12" name="Shape 10"/>
-          <p:cNvSpPr/>
-          <p:nvPr/>
-        </p:nvSpPr>
-        <p:spPr>
-          <a:xfrm>
-            <a:off x="11853367" y="6629400"/>
-            <a:ext cx="109728" cy="0"/>
-          </a:xfrm>
-          <a:prstGeom prst="line">
-            <a:avLst/>
-          </a:prstGeom>
-          <a:noFill/>
-          <a:ln w="6350">
-            <a:solidFill>
-              <a:srgbClr val="1E6F96"/>
-            </a:solidFill>
-            <a:prstDash val="solid"/>
-          </a:ln>
-        </p:spPr>
-        <p:txBody>
-          <a:bodyPr/>
-          <a:lstStyle/>
-          <a:p>
-            <a:endParaRPr lang="en-US"/>
-          </a:p>
-        </p:txBody>
-      </p:sp>
-      <p:sp>
-        <p:nvSpPr>
-          <p:cNvPr id="13" name="Shape 11"/>
-          <p:cNvSpPr/>
-          <p:nvPr/>
-        </p:nvSpPr>
-        <p:spPr>
-          <a:xfrm>
-            <a:off x="11963095" y="6519672"/>
-            <a:ext cx="0" cy="109728"/>
-          </a:xfrm>
-          <a:prstGeom prst="line">
-            <a:avLst/>
-          </a:prstGeom>
-          <a:noFill/>
-          <a:ln w="6350">
-            <a:solidFill>
-              <a:srgbClr val="1E6F96"/>
-            </a:solidFill>
-            <a:prstDash val="solid"/>
-          </a:ln>
-        </p:spPr>
-        <p:txBody>
-          <a:bodyPr/>
-          <a:lstStyle/>
-          <a:p>
-            <a:endParaRPr lang="en-US"/>
-          </a:p>
-        </p:txBody>
-      </p:sp>
-      <p:sp>
-        <p:nvSpPr>
           <p:cNvPr id="14" name="Shape 12"/>
           <p:cNvSpPr/>
           <p:nvPr/>
@@ -16649,7 +16529,7 @@
         </p:nvSpPr>
         <p:spPr>
           <a:xfrm>
-            <a:off x="11094415" y="6537960"/>
+            <a:off x="11091672" y="6537960"/>
             <a:ext cx="731520" cy="201168"/>
           </a:xfrm>
           <a:prstGeom prst="rect">
@@ -16893,7 +16773,7 @@
         <p:spPr>
           <a:xfrm>
             <a:off x="0" y="0"/>
-            <a:ext cx="12191695" cy="36576"/>
+            <a:ext cx="11466576" cy="36576"/>
           </a:xfrm>
           <a:prstGeom prst="rect">
             <a:avLst/>
@@ -17022,7 +16902,7 @@
         <p:spPr>
           <a:xfrm>
             <a:off x="365760" y="411480"/>
-            <a:ext cx="11460175" cy="0"/>
+            <a:ext cx="10881360" cy="0"/>
           </a:xfrm>
           <a:prstGeom prst="line">
             <a:avLst/>
@@ -17300,7 +17180,7 @@
         </p:nvSpPr>
         <p:spPr>
           <a:xfrm>
-            <a:off x="11094415" y="6537960"/>
+            <a:off x="11091672" y="6537960"/>
             <a:ext cx="731520" cy="201168"/>
           </a:xfrm>
           <a:prstGeom prst="rect">
@@ -18124,7 +18004,7 @@
         <p:spPr>
           <a:xfrm>
             <a:off x="0" y="0"/>
-            <a:ext cx="12191695" cy="36576"/>
+            <a:ext cx="11466576" cy="36576"/>
           </a:xfrm>
           <a:prstGeom prst="rect">
             <a:avLst/>
@@ -18253,7 +18133,7 @@
         <p:spPr>
           <a:xfrm>
             <a:off x="365760" y="411480"/>
-            <a:ext cx="11460175" cy="0"/>
+            <a:ext cx="10881360" cy="0"/>
           </a:xfrm>
           <a:prstGeom prst="line">
             <a:avLst/>
@@ -18531,7 +18411,7 @@
         </p:nvSpPr>
         <p:spPr>
           <a:xfrm>
-            <a:off x="11094415" y="6537960"/>
+            <a:off x="11091672" y="6537960"/>
             <a:ext cx="731520" cy="201168"/>
           </a:xfrm>
           <a:prstGeom prst="rect">
@@ -19768,7 +19648,7 @@
         <p:spPr>
           <a:xfrm>
             <a:off x="0" y="0"/>
-            <a:ext cx="12191695" cy="36576"/>
+            <a:ext cx="11466576" cy="36576"/>
           </a:xfrm>
           <a:prstGeom prst="rect">
             <a:avLst/>
@@ -19897,7 +19777,7 @@
         <p:spPr>
           <a:xfrm>
             <a:off x="365760" y="411480"/>
-            <a:ext cx="11460175" cy="0"/>
+            <a:ext cx="10881360" cy="0"/>
           </a:xfrm>
           <a:prstGeom prst="line">
             <a:avLst/>
@@ -20175,7 +20055,7 @@
         </p:nvSpPr>
         <p:spPr>
           <a:xfrm>
-            <a:off x="11094415" y="6537960"/>
+            <a:off x="11091672" y="6537960"/>
             <a:ext cx="731520" cy="201168"/>
           </a:xfrm>
           <a:prstGeom prst="rect">
@@ -20923,7 +20803,7 @@
         <p:spPr>
           <a:xfrm>
             <a:off x="0" y="0"/>
-            <a:ext cx="12191695" cy="36576"/>
+            <a:ext cx="11466576" cy="36576"/>
           </a:xfrm>
           <a:prstGeom prst="rect">
             <a:avLst/>
@@ -21052,7 +20932,7 @@
         <p:spPr>
           <a:xfrm>
             <a:off x="365760" y="411480"/>
-            <a:ext cx="11460175" cy="0"/>
+            <a:ext cx="10881360" cy="0"/>
           </a:xfrm>
           <a:prstGeom prst="line">
             <a:avLst/>
@@ -21330,7 +21210,7 @@
         </p:nvSpPr>
         <p:spPr>
           <a:xfrm>
-            <a:off x="11094415" y="6537960"/>
+            <a:off x="11091672" y="6537960"/>
             <a:ext cx="731520" cy="201168"/>
           </a:xfrm>
           <a:prstGeom prst="rect">
@@ -21511,7 +21391,7 @@
         <p:spPr>
           <a:xfrm>
             <a:off x="0" y="0"/>
-            <a:ext cx="12191695" cy="36576"/>
+            <a:ext cx="11466576" cy="36576"/>
           </a:xfrm>
           <a:prstGeom prst="rect">
             <a:avLst/>
@@ -21616,7 +21496,7 @@
         <p:spPr>
           <a:xfrm>
             <a:off x="365760" y="411480"/>
-            <a:ext cx="11460175" cy="0"/>
+            <a:ext cx="10881360" cy="0"/>
           </a:xfrm>
           <a:prstGeom prst="line">
             <a:avLst/>
@@ -21699,13 +21579,13 @@
       </p:sp>
       <p:sp>
         <p:nvSpPr>
-          <p:cNvPr id="8" name="Shape 6"/>
-          <p:cNvSpPr/>
-          <p:nvPr/>
-        </p:nvSpPr>
-        <p:spPr>
-          <a:xfrm>
-            <a:off x="11853367" y="228600"/>
+          <p:cNvPr id="10" name="Shape 8"/>
+          <p:cNvSpPr/>
+          <p:nvPr/>
+        </p:nvSpPr>
+        <p:spPr>
+          <a:xfrm>
+            <a:off x="228600" y="6629400"/>
             <a:ext cx="109728" cy="0"/>
           </a:xfrm>
           <a:prstGeom prst="line">
@@ -21729,13 +21609,13 @@
       </p:sp>
       <p:sp>
         <p:nvSpPr>
-          <p:cNvPr id="9" name="Shape 7"/>
-          <p:cNvSpPr/>
-          <p:nvPr/>
-        </p:nvSpPr>
-        <p:spPr>
-          <a:xfrm>
-            <a:off x="11963095" y="228600"/>
+          <p:cNvPr id="11" name="Shape 9"/>
+          <p:cNvSpPr/>
+          <p:nvPr/>
+        </p:nvSpPr>
+        <p:spPr>
+          <a:xfrm>
+            <a:off x="228600" y="6519672"/>
             <a:ext cx="0" cy="109728"/>
           </a:xfrm>
           <a:prstGeom prst="line">
@@ -21759,13 +21639,13 @@
       </p:sp>
       <p:sp>
         <p:nvSpPr>
-          <p:cNvPr id="10" name="Shape 8"/>
-          <p:cNvSpPr/>
-          <p:nvPr/>
-        </p:nvSpPr>
-        <p:spPr>
-          <a:xfrm>
-            <a:off x="228600" y="6629400"/>
+          <p:cNvPr id="12" name="Shape 10"/>
+          <p:cNvSpPr/>
+          <p:nvPr/>
+        </p:nvSpPr>
+        <p:spPr>
+          <a:xfrm>
+            <a:off x="11853367" y="6629400"/>
             <a:ext cx="109728" cy="0"/>
           </a:xfrm>
           <a:prstGeom prst="line">
@@ -21789,13 +21669,13 @@
       </p:sp>
       <p:sp>
         <p:nvSpPr>
-          <p:cNvPr id="11" name="Shape 9"/>
-          <p:cNvSpPr/>
-          <p:nvPr/>
-        </p:nvSpPr>
-        <p:spPr>
-          <a:xfrm>
-            <a:off x="228600" y="6519672"/>
+          <p:cNvPr id="13" name="Shape 11"/>
+          <p:cNvSpPr/>
+          <p:nvPr/>
+        </p:nvSpPr>
+        <p:spPr>
+          <a:xfrm>
+            <a:off x="11963095" y="6519672"/>
             <a:ext cx="0" cy="109728"/>
           </a:xfrm>
           <a:prstGeom prst="line">
@@ -21819,66 +21699,6 @@
       </p:sp>
       <p:sp>
         <p:nvSpPr>
-          <p:cNvPr id="12" name="Shape 10"/>
-          <p:cNvSpPr/>
-          <p:nvPr/>
-        </p:nvSpPr>
-        <p:spPr>
-          <a:xfrm>
-            <a:off x="11853367" y="6629400"/>
-            <a:ext cx="109728" cy="0"/>
-          </a:xfrm>
-          <a:prstGeom prst="line">
-            <a:avLst/>
-          </a:prstGeom>
-          <a:noFill/>
-          <a:ln w="6350">
-            <a:solidFill>
-              <a:srgbClr val="1E6F96"/>
-            </a:solidFill>
-            <a:prstDash val="solid"/>
-          </a:ln>
-        </p:spPr>
-        <p:txBody>
-          <a:bodyPr/>
-          <a:lstStyle/>
-          <a:p>
-            <a:endParaRPr lang="en-US"/>
-          </a:p>
-        </p:txBody>
-      </p:sp>
-      <p:sp>
-        <p:nvSpPr>
-          <p:cNvPr id="13" name="Shape 11"/>
-          <p:cNvSpPr/>
-          <p:nvPr/>
-        </p:nvSpPr>
-        <p:spPr>
-          <a:xfrm>
-            <a:off x="11963095" y="6519672"/>
-            <a:ext cx="0" cy="109728"/>
-          </a:xfrm>
-          <a:prstGeom prst="line">
-            <a:avLst/>
-          </a:prstGeom>
-          <a:noFill/>
-          <a:ln w="6350">
-            <a:solidFill>
-              <a:srgbClr val="1E6F96"/>
-            </a:solidFill>
-            <a:prstDash val="solid"/>
-          </a:ln>
-        </p:spPr>
-        <p:txBody>
-          <a:bodyPr/>
-          <a:lstStyle/>
-          <a:p>
-            <a:endParaRPr lang="en-US"/>
-          </a:p>
-        </p:txBody>
-      </p:sp>
-      <p:sp>
-        <p:nvSpPr>
           <p:cNvPr id="14" name="Shape 12"/>
           <p:cNvSpPr/>
           <p:nvPr/>
@@ -21954,7 +21774,7 @@
         </p:nvSpPr>
         <p:spPr>
           <a:xfrm>
-            <a:off x="11094415" y="6537960"/>
+            <a:off x="11091672" y="6537960"/>
             <a:ext cx="731520" cy="201168"/>
           </a:xfrm>
           <a:prstGeom prst="rect">
@@ -22510,7 +22330,7 @@
         <p:spPr>
           <a:xfrm>
             <a:off x="0" y="0"/>
-            <a:ext cx="12191695" cy="36576"/>
+            <a:ext cx="11466576" cy="36576"/>
           </a:xfrm>
           <a:prstGeom prst="rect">
             <a:avLst/>
@@ -22639,7 +22459,7 @@
         <p:spPr>
           <a:xfrm>
             <a:off x="365760" y="411480"/>
-            <a:ext cx="11460175" cy="0"/>
+            <a:ext cx="10881360" cy="0"/>
           </a:xfrm>
           <a:prstGeom prst="line">
             <a:avLst/>
@@ -22917,7 +22737,7 @@
         </p:nvSpPr>
         <p:spPr>
           <a:xfrm>
-            <a:off x="11094415" y="6537960"/>
+            <a:off x="11091672" y="6537960"/>
             <a:ext cx="731520" cy="201168"/>
           </a:xfrm>
           <a:prstGeom prst="rect">
@@ -23941,7 +23761,7 @@
         <p:spPr>
           <a:xfrm>
             <a:off x="0" y="0"/>
-            <a:ext cx="12191695" cy="36576"/>
+            <a:ext cx="11466576" cy="36576"/>
           </a:xfrm>
           <a:prstGeom prst="rect">
             <a:avLst/>
@@ -24070,7 +23890,7 @@
         <p:spPr>
           <a:xfrm>
             <a:off x="365760" y="411480"/>
-            <a:ext cx="11460175" cy="0"/>
+            <a:ext cx="10881360" cy="0"/>
           </a:xfrm>
           <a:prstGeom prst="line">
             <a:avLst/>
@@ -24348,7 +24168,7 @@
         </p:nvSpPr>
         <p:spPr>
           <a:xfrm>
-            <a:off x="11094415" y="6537960"/>
+            <a:off x="11091672" y="6537960"/>
             <a:ext cx="731520" cy="201168"/>
           </a:xfrm>
           <a:prstGeom prst="rect">
@@ -24607,7 +24427,7 @@
         <p:spPr>
           <a:xfrm>
             <a:off x="0" y="0"/>
-            <a:ext cx="12191695" cy="36576"/>
+            <a:ext cx="11466576" cy="36576"/>
           </a:xfrm>
           <a:prstGeom prst="rect">
             <a:avLst/>
@@ -24736,7 +24556,7 @@
         <p:spPr>
           <a:xfrm>
             <a:off x="365760" y="411480"/>
-            <a:ext cx="11460175" cy="0"/>
+            <a:ext cx="10881360" cy="0"/>
           </a:xfrm>
           <a:prstGeom prst="line">
             <a:avLst/>
@@ -25014,7 +24834,7 @@
         </p:nvSpPr>
         <p:spPr>
           <a:xfrm>
-            <a:off x="11094415" y="6537960"/>
+            <a:off x="11091672" y="6537960"/>
             <a:ext cx="731520" cy="201168"/>
           </a:xfrm>
           <a:prstGeom prst="rect">
@@ -25234,7 +25054,7 @@
         <p:spPr>
           <a:xfrm>
             <a:off x="0" y="0"/>
-            <a:ext cx="12191695" cy="36576"/>
+            <a:ext cx="11466576" cy="36576"/>
           </a:xfrm>
           <a:prstGeom prst="rect">
             <a:avLst/>
@@ -25363,7 +25183,7 @@
         <p:spPr>
           <a:xfrm>
             <a:off x="365760" y="411480"/>
-            <a:ext cx="11460175" cy="0"/>
+            <a:ext cx="10881360" cy="0"/>
           </a:xfrm>
           <a:prstGeom prst="line">
             <a:avLst/>
@@ -25641,7 +25461,7 @@
         </p:nvSpPr>
         <p:spPr>
           <a:xfrm>
-            <a:off x="11094415" y="6537960"/>
+            <a:off x="11091672" y="6537960"/>
             <a:ext cx="731520" cy="201168"/>
           </a:xfrm>
           <a:prstGeom prst="rect">
@@ -26498,7 +26318,7 @@
         <p:spPr>
           <a:xfrm>
             <a:off x="0" y="0"/>
-            <a:ext cx="12191695" cy="36576"/>
+            <a:ext cx="11466576" cy="36576"/>
           </a:xfrm>
           <a:prstGeom prst="rect">
             <a:avLst/>
@@ -26627,7 +26447,7 @@
         <p:spPr>
           <a:xfrm>
             <a:off x="365760" y="411480"/>
-            <a:ext cx="11460175" cy="0"/>
+            <a:ext cx="10881360" cy="0"/>
           </a:xfrm>
           <a:prstGeom prst="line">
             <a:avLst/>
@@ -26905,7 +26725,7 @@
         </p:nvSpPr>
         <p:spPr>
           <a:xfrm>
-            <a:off x="11094415" y="6537960"/>
+            <a:off x="11091672" y="6537960"/>
             <a:ext cx="731520" cy="201168"/>
           </a:xfrm>
           <a:prstGeom prst="rect">
@@ -27293,7 +27113,7 @@
         <p:spPr>
           <a:xfrm>
             <a:off x="0" y="0"/>
-            <a:ext cx="12191695" cy="36576"/>
+            <a:ext cx="11466576" cy="36576"/>
           </a:xfrm>
           <a:prstGeom prst="rect">
             <a:avLst/>
@@ -27422,7 +27242,7 @@
         <p:spPr>
           <a:xfrm>
             <a:off x="365760" y="411480"/>
-            <a:ext cx="11460175" cy="0"/>
+            <a:ext cx="10881360" cy="0"/>
           </a:xfrm>
           <a:prstGeom prst="line">
             <a:avLst/>
@@ -27700,7 +27520,7 @@
         </p:nvSpPr>
         <p:spPr>
           <a:xfrm>
-            <a:off x="11094415" y="6537960"/>
+            <a:off x="11091672" y="6537960"/>
             <a:ext cx="731520" cy="201168"/>
           </a:xfrm>
           <a:prstGeom prst="rect">
@@ -28457,7 +28277,7 @@
         <p:spPr>
           <a:xfrm>
             <a:off x="0" y="0"/>
-            <a:ext cx="12191695" cy="36576"/>
+            <a:ext cx="11466576" cy="36576"/>
           </a:xfrm>
           <a:prstGeom prst="rect">
             <a:avLst/>
@@ -28586,7 +28406,7 @@
         <p:spPr>
           <a:xfrm>
             <a:off x="365760" y="411480"/>
-            <a:ext cx="11460175" cy="0"/>
+            <a:ext cx="10881360" cy="0"/>
           </a:xfrm>
           <a:prstGeom prst="line">
             <a:avLst/>
@@ -28864,7 +28684,7 @@
         </p:nvSpPr>
         <p:spPr>
           <a:xfrm>
-            <a:off x="11094415" y="6537960"/>
+            <a:off x="11091672" y="6537960"/>
             <a:ext cx="731520" cy="201168"/>
           </a:xfrm>
           <a:prstGeom prst="rect">

</xml_diff>